<commit_message>
Re-record the demo video with casual, human-typed complaints
Thapar_DeadlockDodgers_Demo.mp4: 2 min 52 s, 1080p, captioned. It opens
on the theme, project and team card, and every complaint is typed on
screen the way people really type:

- "tapping takes forever to register" (cache hit)
- "phone lags when i tap anything" (same plan, different words)
- "screen flickering like crazy" (another plan)
- "dropped it and screen cracked. also touch is slow af" (two plans)
- "battery dies so fast lol" + battery article (live plan, 5.05 s)
- the same article again (stored plan)
- "earbuds wont connect" (fallback)
- "battery drains overnight smh" with a planted URL (0 leaks)

The demo-page screenshot and deck slide 5 now show the casual complaint.
</commit_message>
<xml_diff>
--- a/Thapar_DeadlockDodgers_Submission.pptx
+++ b/Thapar_DeadlockDodgers_Submission.pptx
@@ -6306,7 +6306,7 @@
                 <a:ea typeface="Calibri" pitchFamily="34" charset="-122"/>
                 <a:cs typeface="Calibri" pitchFamily="34" charset="-120"/>
               </a:rPr>
-              <a:t>  — Y: under 5 min · Thapar_DeadlockDodgers_Demo.mp4 (repo root)</a:t>
+              <a:t>  — Y: 2 min 52 s · Thapar_DeadlockDodgers_Demo.mp4 (repo root)</a:t>
             </a:r>
             <a:endParaRPr lang="en-US" sz="2800" dirty="0"/>
           </a:p>
@@ -12099,7 +12099,7 @@
                 </a:solidFill>
                 <a:latin typeface="Calibri"/>
               </a:rPr>
-              <a:t>Demo video: </a:t>
+              <a:t>Demo video (2 min 52 s): </a:t>
             </a:r>
             <a:r>
               <a:rPr sz="1250" b="0" i="0">

</xml_diff>

<commit_message>
Link the demo video on YouTube from the README and the deck
</commit_message>
<xml_diff>
--- a/Thapar_DeadlockDodgers_Submission.pptx
+++ b/Thapar_DeadlockDodgers_Submission.pptx
@@ -6305,8 +6305,9 @@
                 <a:latin typeface="Calibri" pitchFamily="34" charset="0"/>
                 <a:ea typeface="Calibri" pitchFamily="34" charset="-122"/>
                 <a:cs typeface="Calibri" pitchFamily="34" charset="-120"/>
-              </a:rPr>
-              <a:t>  — Y: 2 min 52 s · Thapar_DeadlockDodgers_Demo.mp4 (repo root)</a:t>
+                <a:hlinkClick r:id="rId3"/>
+              </a:rPr>
+              <a:t>  — Y: 2 min 52 s · https://youtu.be/u3FBUJ19Oaw</a:t>
             </a:r>
             <a:endParaRPr lang="en-US" sz="2800" dirty="0"/>
           </a:p>
@@ -12107,8 +12108,9 @@
                   <a:srgbClr val="3F3F5A"/>
                 </a:solidFill>
                 <a:latin typeface="Calibri"/>
-              </a:rPr>
-              <a:t>Thapar_DeadlockDodgers_Demo.mp4 (repo root)</a:t>
+                <a:hlinkClick r:id="rId4"/>
+              </a:rPr>
+              <a:t>https://youtu.be/u3FBUJ19Oaw</a:t>
             </a:r>
           </a:p>
         </p:txBody>

</xml_diff>